<commit_message>
fix: use integer division for flow connector coordinates
Float coordinates (e.g. x="2148840.0") are invalid OOXML and cause
PowerPoint to fail opening the file. Use // and int() to ensure
all connector positions are integers.

Co-Authored-By: Claude Sonnet 4.6 <noreply@anthropic.com>
</commit_message>
<xml_diff>
--- a/output/network-card-csi-v1.1.pptx
+++ b/output/network-card-csi-v1.1.pptx
@@ -6318,8 +6318,8 @@
         </p:nvCxnSpPr>
         <p:spPr>
           <a:xfrm>
-            <a:off x="2148840.0" y="2697480.0"/>
-            <a:ext cx="182880.0" cy="0.0"/>
+            <a:off x="2148840" y="2697480"/>
+            <a:ext cx="182880" cy="0"/>
           </a:xfrm>
           <a:prstGeom prst="line">
             <a:avLst/>
@@ -6443,8 +6443,8 @@
         </p:nvCxnSpPr>
         <p:spPr>
           <a:xfrm>
-            <a:off x="3703320.0" y="2697480.0"/>
-            <a:ext cx="182880.0" cy="0.0"/>
+            <a:off x="3703320" y="2697480"/>
+            <a:ext cx="182880" cy="0"/>
           </a:xfrm>
           <a:prstGeom prst="line">
             <a:avLst/>
@@ -6568,8 +6568,8 @@
         </p:nvCxnSpPr>
         <p:spPr>
           <a:xfrm>
-            <a:off x="5257800.0" y="2697480.0"/>
-            <a:ext cx="182880.0" cy="0.0"/>
+            <a:off x="5257800" y="2697480"/>
+            <a:ext cx="182880" cy="0"/>
           </a:xfrm>
           <a:prstGeom prst="line">
             <a:avLst/>
@@ -6693,8 +6693,8 @@
         </p:nvCxnSpPr>
         <p:spPr>
           <a:xfrm>
-            <a:off x="6812280.0" y="2697480.0"/>
-            <a:ext cx="182880.0" cy="0.0"/>
+            <a:off x="6812280" y="2697480"/>
+            <a:ext cx="182880" cy="0"/>
           </a:xfrm>
           <a:prstGeom prst="line">
             <a:avLst/>
@@ -17635,8 +17635,8 @@
         </p:nvCxnSpPr>
         <p:spPr>
           <a:xfrm>
-            <a:off x="2148840.0" y="2697480.0"/>
-            <a:ext cx="182880.0" cy="0.0"/>
+            <a:off x="2148840" y="2697480"/>
+            <a:ext cx="182880" cy="0"/>
           </a:xfrm>
           <a:prstGeom prst="line">
             <a:avLst/>
@@ -17760,8 +17760,8 @@
         </p:nvCxnSpPr>
         <p:spPr>
           <a:xfrm>
-            <a:off x="3703320.0" y="2697480.0"/>
-            <a:ext cx="182880.0" cy="0.0"/>
+            <a:off x="3703320" y="2697480"/>
+            <a:ext cx="182880" cy="0"/>
           </a:xfrm>
           <a:prstGeom prst="line">
             <a:avLst/>
@@ -17885,8 +17885,8 @@
         </p:nvCxnSpPr>
         <p:spPr>
           <a:xfrm>
-            <a:off x="5257800.0" y="2697480.0"/>
-            <a:ext cx="182880.0" cy="0.0"/>
+            <a:off x="5257800" y="2697480"/>
+            <a:ext cx="182880" cy="0"/>
           </a:xfrm>
           <a:prstGeom prst="line">
             <a:avLst/>
@@ -18010,8 +18010,8 @@
         </p:nvCxnSpPr>
         <p:spPr>
           <a:xfrm>
-            <a:off x="6812280.0" y="2697480.0"/>
-            <a:ext cx="182880.0" cy="0.0"/>
+            <a:off x="6812280" y="2697480"/>
+            <a:ext cx="182880" cy="0"/>
           </a:xfrm>
           <a:prstGeom prst="line">
             <a:avLst/>

</xml_diff>